<commit_message>
Aggiunta visualizzazione dinamica per quanto riguarda la finale argentina francia
</commit_message>
<xml_diff>
--- a/presentazioneAVRC.pptx
+++ b/presentazioneAVRC.pptx
@@ -576,7 +576,7 @@
           </a:lstStyle>
           <a:p>
             <a:fld id="{4FA906EC-296A-4158-9F24-BE49A6B020EC}" type="datetimeFigureOut">
-              <a:t>24/05/2026</a:t>
+              <a:t>25/05/2026</a:t>
             </a:fld>
             <a:endParaRPr lang="it-IT"/>
           </a:p>
@@ -2355,744 +2355,104 @@
       </p:grpSpPr>
       <p:sp>
         <p:nvSpPr>
-          <p:cNvPr id="2" name="Text 0"/>
-          <p:cNvSpPr/>
-          <p:nvPr/>
-        </p:nvSpPr>
-        <p:spPr>
-          <a:xfrm>
-            <a:off x="548640" y="365760"/>
-            <a:ext cx="8229600" cy="502920"/>
-          </a:xfrm>
-          <a:prstGeom prst="rect">
-            <a:avLst/>
-          </a:prstGeom>
-          <a:noFill/>
-          <a:ln/>
-        </p:spPr>
-        <p:txBody>
-          <a:bodyPr wrap="square" lIns="0" tIns="0" rIns="0" bIns="0" rtlCol="0" anchor="ctr"/>
-          <a:lstStyle/>
-          <a:p>
-            <a:pPr marL="0" indent="0">
-              <a:buNone/>
-            </a:pPr>
-            <a:r>
-              <a:rPr lang="en-US" sz="2800" b="1" dirty="0">
-                <a:solidFill>
-                  <a:srgbClr val="FFFFFF"/>
-                </a:solidFill>
-                <a:latin typeface="Cambria" pitchFamily="34" charset="0"/>
-                <a:ea typeface="Cambria" pitchFamily="34" charset="-122"/>
-                <a:cs typeface="Cambria" pitchFamily="34" charset="-120"/>
-              </a:rPr>
-              <a:t>In sintesi</a:t>
-            </a:r>
-            <a:endParaRPr lang="en-US" sz="2800" dirty="0"/>
-          </a:p>
-        </p:txBody>
-      </p:sp>
-      <p:sp>
-        <p:nvSpPr>
-          <p:cNvPr id="3" name="Text 1"/>
-          <p:cNvSpPr/>
-          <p:nvPr/>
-        </p:nvSpPr>
-        <p:spPr>
-          <a:xfrm>
-            <a:off x="548640" y="868680"/>
-            <a:ext cx="8229600" cy="320040"/>
-          </a:xfrm>
-          <a:prstGeom prst="rect">
-            <a:avLst/>
-          </a:prstGeom>
-          <a:noFill/>
-          <a:ln/>
-        </p:spPr>
-        <p:txBody>
-          <a:bodyPr wrap="square" lIns="0" tIns="0" rIns="0" bIns="0" rtlCol="0" anchor="ctr"/>
-          <a:lstStyle/>
-          <a:p>
-            <a:pPr marL="0" indent="0">
-              <a:buNone/>
-            </a:pPr>
-            <a:r>
-              <a:rPr lang="en-US" sz="1300" i="1" dirty="0">
-                <a:solidFill>
-                  <a:srgbClr val="E5C97A"/>
-                </a:solidFill>
-                <a:latin typeface="Calibri" pitchFamily="34" charset="0"/>
-                <a:ea typeface="Calibri" pitchFamily="34" charset="-122"/>
-                <a:cs typeface="Calibri" pitchFamily="34" charset="-120"/>
-              </a:rPr>
-              <a:t>dove siamo, dove vogliamo arrivare</a:t>
-            </a:r>
-            <a:endParaRPr lang="en-US" sz="1300" dirty="0"/>
-          </a:p>
-        </p:txBody>
-      </p:sp>
-      <p:sp>
-        <p:nvSpPr>
-          <p:cNvPr id="4" name="Shape 2"/>
-          <p:cNvSpPr/>
-          <p:nvPr/>
-        </p:nvSpPr>
-        <p:spPr>
-          <a:xfrm>
-            <a:off x="640080" y="1600200"/>
-            <a:ext cx="502920" cy="502920"/>
-          </a:xfrm>
-          <a:prstGeom prst="ellipse">
-            <a:avLst/>
-          </a:prstGeom>
-          <a:solidFill>
-            <a:srgbClr val="1E3A2D"/>
-          </a:solidFill>
-          <a:ln w="25400">
-            <a:solidFill>
-              <a:srgbClr val="C9A14A"/>
-            </a:solidFill>
-            <a:prstDash val="solid"/>
-          </a:ln>
-        </p:spPr>
-        <p:txBody>
-          <a:bodyPr/>
-          <a:lstStyle/>
-          <a:p>
-            <a:endParaRPr lang="it-IT"/>
-          </a:p>
-        </p:txBody>
-      </p:sp>
-      <p:sp>
-        <p:nvSpPr>
-          <p:cNvPr id="5" name="Text 3"/>
-          <p:cNvSpPr/>
-          <p:nvPr/>
-        </p:nvSpPr>
-        <p:spPr>
-          <a:xfrm>
-            <a:off x="640080" y="1600200"/>
-            <a:ext cx="502920" cy="502920"/>
-          </a:xfrm>
-          <a:prstGeom prst="rect">
-            <a:avLst/>
-          </a:prstGeom>
-          <a:noFill/>
-          <a:ln/>
-        </p:spPr>
-        <p:txBody>
-          <a:bodyPr wrap="square" lIns="0" tIns="0" rIns="0" bIns="0" rtlCol="0" anchor="ctr"/>
-          <a:lstStyle/>
-          <a:p>
-            <a:pPr marL="0" indent="0" algn="ctr">
-              <a:buNone/>
-            </a:pPr>
-            <a:r>
-              <a:rPr lang="en-US" sz="2400" b="1" dirty="0">
-                <a:solidFill>
-                  <a:srgbClr val="C9A14A"/>
-                </a:solidFill>
-                <a:latin typeface="Cambria" pitchFamily="34" charset="0"/>
-                <a:ea typeface="Cambria" pitchFamily="34" charset="-122"/>
-                <a:cs typeface="Cambria" pitchFamily="34" charset="-120"/>
-              </a:rPr>
-              <a:t>1</a:t>
-            </a:r>
-            <a:endParaRPr lang="en-US" sz="2400" dirty="0"/>
-          </a:p>
-        </p:txBody>
-      </p:sp>
-      <p:sp>
-        <p:nvSpPr>
-          <p:cNvPr id="6" name="Text 4"/>
-          <p:cNvSpPr/>
-          <p:nvPr/>
-        </p:nvSpPr>
-        <p:spPr>
-          <a:xfrm>
-            <a:off x="1325880" y="1600200"/>
-            <a:ext cx="3063240" cy="365760"/>
-          </a:xfrm>
-          <a:prstGeom prst="rect">
-            <a:avLst/>
-          </a:prstGeom>
-          <a:noFill/>
-          <a:ln/>
-        </p:spPr>
-        <p:txBody>
-          <a:bodyPr wrap="square" lIns="0" tIns="0" rIns="0" bIns="0" rtlCol="0" anchor="ctr"/>
-          <a:lstStyle/>
-          <a:p>
-            <a:pPr marL="0" indent="0">
-              <a:buNone/>
-            </a:pPr>
-            <a:r>
-              <a:rPr lang="en-US" sz="1700" b="1" dirty="0">
-                <a:solidFill>
-                  <a:srgbClr val="FFFFFF"/>
-                </a:solidFill>
-                <a:latin typeface="Cambria" pitchFamily="34" charset="0"/>
-                <a:ea typeface="Cambria" pitchFamily="34" charset="-122"/>
-                <a:cs typeface="Cambria" pitchFamily="34" charset="-120"/>
-              </a:rPr>
-              <a:t>Idea solida</a:t>
-            </a:r>
-            <a:endParaRPr lang="en-US" sz="1700" dirty="0"/>
-          </a:p>
-        </p:txBody>
-      </p:sp>
-      <p:sp>
-        <p:nvSpPr>
-          <p:cNvPr id="7" name="Text 5"/>
-          <p:cNvSpPr/>
-          <p:nvPr/>
-        </p:nvSpPr>
-        <p:spPr>
-          <a:xfrm>
-            <a:off x="1325880" y="2011680"/>
-            <a:ext cx="3063240" cy="731520"/>
-          </a:xfrm>
-          <a:prstGeom prst="rect">
-            <a:avLst/>
-          </a:prstGeom>
-          <a:noFill/>
-          <a:ln/>
-        </p:spPr>
-        <p:txBody>
-          <a:bodyPr wrap="square" lIns="0" tIns="0" rIns="0" bIns="0" rtlCol="0" anchor="ctr"/>
-          <a:lstStyle/>
-          <a:p>
-            <a:pPr marL="0" indent="0">
-              <a:buNone/>
-            </a:pPr>
-            <a:r>
-              <a:rPr lang="en-US" sz="1150" dirty="0">
-                <a:solidFill>
-                  <a:srgbClr val="E5C97A"/>
-                </a:solidFill>
-                <a:latin typeface="Calibri" pitchFamily="34" charset="0"/>
-                <a:ea typeface="Calibri" pitchFamily="34" charset="-122"/>
-                <a:cs typeface="Calibri" pitchFamily="34" charset="-120"/>
-              </a:rPr>
-              <a:t>una rete narrativa naturale, ground truth verificabile, scala adatta al syllabus completo.</a:t>
-            </a:r>
-            <a:endParaRPr lang="en-US" sz="1150" dirty="0"/>
-          </a:p>
-        </p:txBody>
-      </p:sp>
-      <p:sp>
-        <p:nvSpPr>
-          <p:cNvPr id="8" name="Shape 6"/>
-          <p:cNvSpPr/>
-          <p:nvPr/>
-        </p:nvSpPr>
-        <p:spPr>
-          <a:xfrm>
-            <a:off x="4754880" y="1600200"/>
-            <a:ext cx="502920" cy="502920"/>
-          </a:xfrm>
-          <a:prstGeom prst="ellipse">
-            <a:avLst/>
-          </a:prstGeom>
-          <a:solidFill>
-            <a:srgbClr val="1E3A2D"/>
-          </a:solidFill>
-          <a:ln w="25400">
-            <a:solidFill>
-              <a:srgbClr val="C9A14A"/>
-            </a:solidFill>
-            <a:prstDash val="solid"/>
-          </a:ln>
-        </p:spPr>
-        <p:txBody>
-          <a:bodyPr/>
-          <a:lstStyle/>
-          <a:p>
-            <a:endParaRPr lang="it-IT"/>
-          </a:p>
-        </p:txBody>
-      </p:sp>
-      <p:sp>
-        <p:nvSpPr>
-          <p:cNvPr id="9" name="Text 7"/>
-          <p:cNvSpPr/>
-          <p:nvPr/>
-        </p:nvSpPr>
-        <p:spPr>
-          <a:xfrm>
-            <a:off x="4754880" y="1600200"/>
-            <a:ext cx="502920" cy="502920"/>
-          </a:xfrm>
-          <a:prstGeom prst="rect">
-            <a:avLst/>
-          </a:prstGeom>
-          <a:noFill/>
-          <a:ln/>
-        </p:spPr>
-        <p:txBody>
-          <a:bodyPr wrap="square" lIns="0" tIns="0" rIns="0" bIns="0" rtlCol="0" anchor="ctr"/>
-          <a:lstStyle/>
-          <a:p>
-            <a:pPr marL="0" indent="0" algn="ctr">
-              <a:buNone/>
-            </a:pPr>
-            <a:r>
-              <a:rPr lang="en-US" sz="2400" b="1" dirty="0">
-                <a:solidFill>
-                  <a:srgbClr val="C9A14A"/>
-                </a:solidFill>
-                <a:latin typeface="Cambria" pitchFamily="34" charset="0"/>
-                <a:ea typeface="Cambria" pitchFamily="34" charset="-122"/>
-                <a:cs typeface="Cambria" pitchFamily="34" charset="-120"/>
-              </a:rPr>
-              <a:t>2</a:t>
-            </a:r>
-            <a:endParaRPr lang="en-US" sz="2400" dirty="0"/>
-          </a:p>
-        </p:txBody>
-      </p:sp>
-      <p:sp>
-        <p:nvSpPr>
-          <p:cNvPr id="10" name="Text 8"/>
-          <p:cNvSpPr/>
-          <p:nvPr/>
-        </p:nvSpPr>
-        <p:spPr>
-          <a:xfrm>
-            <a:off x="5440680" y="1600200"/>
-            <a:ext cx="3063240" cy="365760"/>
-          </a:xfrm>
-          <a:prstGeom prst="rect">
-            <a:avLst/>
-          </a:prstGeom>
-          <a:noFill/>
-          <a:ln/>
-        </p:spPr>
-        <p:txBody>
-          <a:bodyPr wrap="square" lIns="0" tIns="0" rIns="0" bIns="0" rtlCol="0" anchor="ctr"/>
-          <a:lstStyle/>
-          <a:p>
-            <a:pPr marL="0" indent="0">
-              <a:buNone/>
-            </a:pPr>
-            <a:r>
-              <a:rPr lang="en-US" sz="1700" b="1" dirty="0">
-                <a:solidFill>
-                  <a:srgbClr val="FFFFFF"/>
-                </a:solidFill>
-                <a:latin typeface="Cambria" pitchFamily="34" charset="0"/>
-                <a:ea typeface="Cambria" pitchFamily="34" charset="-122"/>
-                <a:cs typeface="Cambria" pitchFamily="34" charset="-120"/>
-              </a:rPr>
-              <a:t>Pipeline funzionante</a:t>
-            </a:r>
-            <a:endParaRPr lang="en-US" sz="1700" dirty="0"/>
-          </a:p>
-        </p:txBody>
-      </p:sp>
-      <p:sp>
-        <p:nvSpPr>
-          <p:cNvPr id="11" name="Text 9"/>
-          <p:cNvSpPr/>
-          <p:nvPr/>
-        </p:nvSpPr>
-        <p:spPr>
-          <a:xfrm>
-            <a:off x="5440680" y="2011680"/>
-            <a:ext cx="3063240" cy="731520"/>
-          </a:xfrm>
-          <a:prstGeom prst="rect">
-            <a:avLst/>
-          </a:prstGeom>
-          <a:noFill/>
-          <a:ln/>
-        </p:spPr>
-        <p:txBody>
-          <a:bodyPr wrap="square" lIns="0" tIns="0" rIns="0" bIns="0" rtlCol="0" anchor="ctr"/>
-          <a:lstStyle/>
-          <a:p>
-            <a:pPr marL="0" indent="0">
-              <a:buNone/>
-            </a:pPr>
-            <a:r>
-              <a:rPr lang="en-US" sz="1150" dirty="0">
-                <a:solidFill>
-                  <a:srgbClr val="E5C97A"/>
-                </a:solidFill>
-                <a:latin typeface="Calibri" pitchFamily="34" charset="0"/>
-                <a:ea typeface="Calibri" pitchFamily="34" charset="-122"/>
-                <a:cs typeface="Calibri" pitchFamily="34" charset="-120"/>
-              </a:rPr>
-              <a:t>23 file JSON di StatsBomb → 4 grafi NetworkX pronti in 8 secondi su laptop.</a:t>
-            </a:r>
-            <a:endParaRPr lang="en-US" sz="1150" dirty="0"/>
-          </a:p>
-        </p:txBody>
-      </p:sp>
-      <p:sp>
-        <p:nvSpPr>
-          <p:cNvPr id="12" name="Shape 10"/>
-          <p:cNvSpPr/>
-          <p:nvPr/>
-        </p:nvSpPr>
-        <p:spPr>
-          <a:xfrm>
-            <a:off x="640080" y="3154680"/>
-            <a:ext cx="502920" cy="502920"/>
-          </a:xfrm>
-          <a:prstGeom prst="ellipse">
-            <a:avLst/>
-          </a:prstGeom>
-          <a:solidFill>
-            <a:srgbClr val="1E3A2D"/>
-          </a:solidFill>
-          <a:ln w="25400">
-            <a:solidFill>
-              <a:srgbClr val="C9A14A"/>
-            </a:solidFill>
-            <a:prstDash val="solid"/>
-          </a:ln>
-        </p:spPr>
-        <p:txBody>
-          <a:bodyPr/>
-          <a:lstStyle/>
-          <a:p>
-            <a:endParaRPr lang="it-IT"/>
-          </a:p>
-        </p:txBody>
-      </p:sp>
-      <p:sp>
-        <p:nvSpPr>
-          <p:cNvPr id="13" name="Text 11"/>
-          <p:cNvSpPr/>
-          <p:nvPr/>
-        </p:nvSpPr>
-        <p:spPr>
-          <a:xfrm>
-            <a:off x="640080" y="3154680"/>
-            <a:ext cx="502920" cy="502920"/>
-          </a:xfrm>
-          <a:prstGeom prst="rect">
-            <a:avLst/>
-          </a:prstGeom>
-          <a:noFill/>
-          <a:ln/>
-        </p:spPr>
-        <p:txBody>
-          <a:bodyPr wrap="square" lIns="0" tIns="0" rIns="0" bIns="0" rtlCol="0" anchor="ctr"/>
-          <a:lstStyle/>
-          <a:p>
-            <a:pPr marL="0" indent="0" algn="ctr">
-              <a:buNone/>
-            </a:pPr>
-            <a:r>
-              <a:rPr lang="en-US" sz="2400" b="1" dirty="0">
-                <a:solidFill>
-                  <a:srgbClr val="C9A14A"/>
-                </a:solidFill>
-                <a:latin typeface="Cambria" pitchFamily="34" charset="0"/>
-                <a:ea typeface="Cambria" pitchFamily="34" charset="-122"/>
-                <a:cs typeface="Cambria" pitchFamily="34" charset="-120"/>
-              </a:rPr>
-              <a:t>3</a:t>
-            </a:r>
-            <a:endParaRPr lang="en-US" sz="2400" dirty="0"/>
-          </a:p>
-        </p:txBody>
-      </p:sp>
-      <p:sp>
-        <p:nvSpPr>
-          <p:cNvPr id="14" name="Text 12"/>
-          <p:cNvSpPr/>
-          <p:nvPr/>
-        </p:nvSpPr>
-        <p:spPr>
-          <a:xfrm>
-            <a:off x="1325880" y="3154680"/>
-            <a:ext cx="3063240" cy="365760"/>
-          </a:xfrm>
-          <a:prstGeom prst="rect">
-            <a:avLst/>
-          </a:prstGeom>
-          <a:noFill/>
-          <a:ln/>
-        </p:spPr>
-        <p:txBody>
-          <a:bodyPr wrap="square" lIns="0" tIns="0" rIns="0" bIns="0" rtlCol="0" anchor="ctr"/>
-          <a:lstStyle/>
-          <a:p>
-            <a:pPr marL="0" indent="0">
-              <a:buNone/>
-            </a:pPr>
-            <a:r>
-              <a:rPr lang="en-US" sz="1700" b="1" dirty="0">
-                <a:solidFill>
-                  <a:srgbClr val="FFFFFF"/>
-                </a:solidFill>
-                <a:latin typeface="Cambria" pitchFamily="34" charset="0"/>
-                <a:ea typeface="Cambria" pitchFamily="34" charset="-122"/>
-                <a:cs typeface="Cambria" pitchFamily="34" charset="-120"/>
-              </a:rPr>
-              <a:t>Un finding già in mano</a:t>
-            </a:r>
-            <a:endParaRPr lang="en-US" sz="1700" dirty="0"/>
-          </a:p>
-        </p:txBody>
-      </p:sp>
-      <p:sp>
-        <p:nvSpPr>
-          <p:cNvPr id="15" name="Text 13"/>
-          <p:cNvSpPr/>
-          <p:nvPr/>
-        </p:nvSpPr>
-        <p:spPr>
-          <a:xfrm>
-            <a:off x="1325880" y="3566160"/>
-            <a:ext cx="3063240" cy="731520"/>
-          </a:xfrm>
-          <a:prstGeom prst="rect">
-            <a:avLst/>
-          </a:prstGeom>
-          <a:noFill/>
-          <a:ln/>
-        </p:spPr>
-        <p:txBody>
-          <a:bodyPr wrap="square" lIns="0" tIns="0" rIns="0" bIns="0" rtlCol="0" anchor="ctr"/>
-          <a:lstStyle/>
-          <a:p>
-            <a:pPr marL="0" indent="0">
-              <a:buNone/>
-            </a:pPr>
-            <a:r>
-              <a:rPr lang="en-US" sz="1150" dirty="0">
-                <a:solidFill>
-                  <a:srgbClr val="E5C97A"/>
-                </a:solidFill>
-                <a:latin typeface="Calibri" pitchFamily="34" charset="0"/>
-                <a:ea typeface="Calibri" pitchFamily="34" charset="-122"/>
-                <a:cs typeface="Calibri" pitchFamily="34" charset="-120"/>
-              </a:rPr>
-              <a:t>r = +0.88 fra dominanza (RQ1) e fragilità (RQ3), su quattro semifinaliste.</a:t>
-            </a:r>
-            <a:endParaRPr lang="en-US" sz="1150" dirty="0"/>
-          </a:p>
-        </p:txBody>
-      </p:sp>
-      <p:sp>
-        <p:nvSpPr>
-          <p:cNvPr id="16" name="Shape 14"/>
-          <p:cNvSpPr/>
-          <p:nvPr/>
-        </p:nvSpPr>
-        <p:spPr>
-          <a:xfrm>
-            <a:off x="4754880" y="3154680"/>
-            <a:ext cx="502920" cy="502920"/>
-          </a:xfrm>
-          <a:prstGeom prst="ellipse">
-            <a:avLst/>
-          </a:prstGeom>
-          <a:solidFill>
-            <a:srgbClr val="1E3A2D"/>
-          </a:solidFill>
-          <a:ln w="25400">
-            <a:solidFill>
-              <a:srgbClr val="C9A14A"/>
-            </a:solidFill>
-            <a:prstDash val="solid"/>
-          </a:ln>
-        </p:spPr>
-        <p:txBody>
-          <a:bodyPr/>
-          <a:lstStyle/>
-          <a:p>
-            <a:endParaRPr lang="it-IT"/>
-          </a:p>
-        </p:txBody>
-      </p:sp>
-      <p:sp>
-        <p:nvSpPr>
-          <p:cNvPr id="17" name="Text 15"/>
-          <p:cNvSpPr/>
-          <p:nvPr/>
-        </p:nvSpPr>
-        <p:spPr>
-          <a:xfrm>
-            <a:off x="4754880" y="3154680"/>
-            <a:ext cx="502920" cy="502920"/>
-          </a:xfrm>
-          <a:prstGeom prst="rect">
-            <a:avLst/>
-          </a:prstGeom>
-          <a:noFill/>
-          <a:ln/>
-        </p:spPr>
-        <p:txBody>
-          <a:bodyPr wrap="square" lIns="0" tIns="0" rIns="0" bIns="0" rtlCol="0" anchor="ctr"/>
-          <a:lstStyle/>
-          <a:p>
-            <a:pPr marL="0" indent="0" algn="ctr">
-              <a:buNone/>
-            </a:pPr>
-            <a:r>
-              <a:rPr lang="en-US" sz="2400" b="1" dirty="0">
-                <a:solidFill>
-                  <a:srgbClr val="C9A14A"/>
-                </a:solidFill>
-                <a:latin typeface="Cambria" pitchFamily="34" charset="0"/>
-                <a:ea typeface="Cambria" pitchFamily="34" charset="-122"/>
-                <a:cs typeface="Cambria" pitchFamily="34" charset="-120"/>
-              </a:rPr>
-              <a:t>4</a:t>
-            </a:r>
-            <a:endParaRPr lang="en-US" sz="2400" dirty="0"/>
-          </a:p>
-        </p:txBody>
-      </p:sp>
-      <p:sp>
-        <p:nvSpPr>
-          <p:cNvPr id="18" name="Text 16"/>
-          <p:cNvSpPr/>
-          <p:nvPr/>
-        </p:nvSpPr>
-        <p:spPr>
-          <a:xfrm>
-            <a:off x="5440680" y="3154680"/>
-            <a:ext cx="3063240" cy="365760"/>
-          </a:xfrm>
-          <a:prstGeom prst="rect">
-            <a:avLst/>
-          </a:prstGeom>
-          <a:noFill/>
-          <a:ln/>
-        </p:spPr>
-        <p:txBody>
-          <a:bodyPr wrap="square" lIns="0" tIns="0" rIns="0" bIns="0" rtlCol="0" anchor="ctr"/>
-          <a:lstStyle/>
-          <a:p>
-            <a:pPr marL="0" indent="0">
-              <a:buNone/>
-            </a:pPr>
-            <a:r>
-              <a:rPr lang="en-US" sz="1700" b="1" dirty="0">
-                <a:solidFill>
-                  <a:srgbClr val="FFFFFF"/>
-                </a:solidFill>
-                <a:latin typeface="Cambria" pitchFamily="34" charset="0"/>
-                <a:ea typeface="Cambria" pitchFamily="34" charset="-122"/>
-                <a:cs typeface="Cambria" pitchFamily="34" charset="-120"/>
-              </a:rPr>
-              <a:t>Roadmap chiara</a:t>
-            </a:r>
-            <a:endParaRPr lang="en-US" sz="1700" dirty="0"/>
-          </a:p>
-        </p:txBody>
-      </p:sp>
-      <p:sp>
-        <p:nvSpPr>
-          <p:cNvPr id="19" name="Text 17"/>
-          <p:cNvSpPr/>
-          <p:nvPr/>
-        </p:nvSpPr>
-        <p:spPr>
-          <a:xfrm>
-            <a:off x="5440680" y="3566160"/>
-            <a:ext cx="3063240" cy="731520"/>
-          </a:xfrm>
-          <a:prstGeom prst="rect">
-            <a:avLst/>
-          </a:prstGeom>
-          <a:noFill/>
-          <a:ln/>
-        </p:spPr>
-        <p:txBody>
-          <a:bodyPr wrap="square" lIns="0" tIns="0" rIns="0" bIns="0" rtlCol="0" anchor="ctr"/>
-          <a:lstStyle/>
-          <a:p>
-            <a:pPr marL="0" indent="0">
-              <a:buNone/>
-            </a:pPr>
-            <a:r>
-              <a:rPr lang="en-US" sz="1150" dirty="0">
-                <a:solidFill>
-                  <a:srgbClr val="E5C97A"/>
-                </a:solidFill>
-                <a:latin typeface="Calibri" pitchFamily="34" charset="0"/>
-                <a:ea typeface="Calibri" pitchFamily="34" charset="-122"/>
-                <a:cs typeface="Calibri" pitchFamily="34" charset="-120"/>
-              </a:rPr>
-              <a:t>RQ1 e RQ2 da chiudere, poi visualizzazioni e — se possibile — l'app Streamlit.</a:t>
-            </a:r>
-            <a:endParaRPr lang="en-US" sz="1150" dirty="0"/>
-          </a:p>
-        </p:txBody>
-      </p:sp>
-      <p:sp>
-        <p:nvSpPr>
-          <p:cNvPr id="20" name="Text 18"/>
-          <p:cNvSpPr/>
-          <p:nvPr/>
-        </p:nvSpPr>
-        <p:spPr>
-          <a:xfrm>
-            <a:off x="548640" y="4343400"/>
-            <a:ext cx="8229600" cy="502920"/>
-          </a:xfrm>
-          <a:prstGeom prst="rect">
-            <a:avLst/>
-          </a:prstGeom>
-          <a:noFill/>
-          <a:ln/>
-        </p:spPr>
-        <p:txBody>
-          <a:bodyPr wrap="square" lIns="0" tIns="0" rIns="0" bIns="0" rtlCol="0" anchor="ctr"/>
-          <a:lstStyle/>
-          <a:p>
-            <a:pPr marL="0" indent="0">
-              <a:buNone/>
-            </a:pPr>
-            <a:r>
-              <a:rPr lang="en-US" sz="2400" i="1" dirty="0">
-                <a:solidFill>
-                  <a:srgbClr val="C9A14A"/>
-                </a:solidFill>
-                <a:latin typeface="Cambria" pitchFamily="34" charset="0"/>
-                <a:ea typeface="Cambria" pitchFamily="34" charset="-122"/>
-                <a:cs typeface="Cambria" pitchFamily="34" charset="-120"/>
-              </a:rPr>
-              <a:t>Grazie. Domande?</a:t>
-            </a:r>
-            <a:endParaRPr lang="en-US" sz="2400" dirty="0"/>
-          </a:p>
-        </p:txBody>
-      </p:sp>
-      <p:sp>
-        <p:nvSpPr>
-          <p:cNvPr id="21" name="Shape 19"/>
-          <p:cNvSpPr/>
-          <p:nvPr/>
-        </p:nvSpPr>
-        <p:spPr>
-          <a:xfrm>
-            <a:off x="457200" y="4846320"/>
-            <a:ext cx="8229600" cy="0"/>
-          </a:xfrm>
-          <a:prstGeom prst="line">
-            <a:avLst/>
-          </a:prstGeom>
-          <a:noFill/>
-          <a:ln w="12700">
-            <a:solidFill>
-              <a:srgbClr val="C9A14A"/>
-            </a:solidFill>
-            <a:prstDash val="solid"/>
-          </a:ln>
-        </p:spPr>
-        <p:txBody>
-          <a:bodyPr/>
-          <a:lstStyle/>
-          <a:p>
-            <a:endParaRPr lang="it-IT"/>
+          <p:cNvPr id="24" name="CasellaDiTesto 23">
+            <a:extLst>
+              <a:ext uri="{FF2B5EF4-FFF2-40B4-BE49-F238E27FC236}">
+                <a16:creationId xmlns:a16="http://schemas.microsoft.com/office/drawing/2014/main" id="{C0ADACB7-FA1D-C3F2-0855-A4C61F66616E}"/>
+              </a:ext>
+            </a:extLst>
+          </p:cNvPr>
+          <p:cNvSpPr txBox="1"/>
+          <p:nvPr/>
+        </p:nvSpPr>
+        <p:spPr>
+          <a:xfrm>
+            <a:off x="1273126" y="1774095"/>
+            <a:ext cx="6495757" cy="1595309"/>
+          </a:xfrm>
+          <a:prstGeom prst="rect">
+            <a:avLst/>
+          </a:prstGeom>
+          <a:noFill/>
+        </p:spPr>
+        <p:txBody>
+          <a:bodyPr wrap="square">
+            <a:spAutoFit/>
+          </a:bodyPr>
+          <a:lstStyle/>
+          <a:p>
+            <a:pPr algn="ctr">
+              <a:spcAft>
+                <a:spcPts val="1500"/>
+              </a:spcAft>
+              <a:buNone/>
+            </a:pPr>
+            <a:r>
+              <a:rPr lang="it-IT" sz="4000" b="1" i="0" dirty="0">
+                <a:solidFill>
+                  <a:schemeClr val="bg1"/>
+                </a:solidFill>
+                <a:effectLst/>
+                <a:latin typeface="Crimson Pro"/>
+              </a:rPr>
+              <a:t>Grazie </a:t>
+            </a:r>
+            <a:r>
+              <a:rPr lang="it-IT" sz="4000" b="1">
+                <a:solidFill>
+                  <a:schemeClr val="bg1"/>
+                </a:solidFill>
+                <a:latin typeface="Crimson Pro"/>
+              </a:rPr>
+              <a:t>per </a:t>
+            </a:r>
+            <a:r>
+              <a:rPr lang="it-IT" sz="4000" b="1" u="sng">
+                <a:solidFill>
+                  <a:schemeClr val="bg1"/>
+                </a:solidFill>
+                <a:latin typeface="Crimson Pro"/>
+              </a:rPr>
+              <a:t>l’</a:t>
+            </a:r>
+            <a:r>
+              <a:rPr lang="it-IT" sz="4000" b="1" i="0" u="sng">
+                <a:solidFill>
+                  <a:schemeClr val="bg1"/>
+                </a:solidFill>
+                <a:effectLst/>
+                <a:latin typeface="Crimson Pro"/>
+              </a:rPr>
+              <a:t>attenzione</a:t>
+            </a:r>
+            <a:endParaRPr lang="it-IT" sz="4000" b="1" i="0" u="sng" dirty="0">
+              <a:solidFill>
+                <a:schemeClr val="bg1"/>
+              </a:solidFill>
+              <a:effectLst/>
+              <a:latin typeface="Crimson Pro"/>
+            </a:endParaRPr>
+          </a:p>
+          <a:p>
+            <a:pPr algn="ctr">
+              <a:spcBef>
+                <a:spcPts val="1125"/>
+              </a:spcBef>
+              <a:buNone/>
+            </a:pPr>
+            <a:r>
+              <a:rPr lang="it-IT" b="1" i="0" dirty="0">
+                <a:solidFill>
+                  <a:schemeClr val="accent2">
+                    <a:lumMod val="40000"/>
+                    <a:lumOff val="60000"/>
+                  </a:schemeClr>
+                </a:solidFill>
+                <a:effectLst/>
+                <a:latin typeface="Public Sans"/>
+              </a:rPr>
+              <a:t>Siamo aperti a domande e suggerimenti sulla metodologia proposta.</a:t>
+            </a:r>
           </a:p>
         </p:txBody>
       </p:sp>
@@ -3286,7 +2646,7 @@
         </p:nvSpPr>
         <p:spPr>
           <a:xfrm>
-            <a:off x="365760" y="1920240"/>
+            <a:off x="365760" y="1417320"/>
             <a:ext cx="4389120" cy="1463040"/>
           </a:xfrm>
           <a:prstGeom prst="rect">
@@ -3388,7 +2748,7 @@
         </p:nvSpPr>
         <p:spPr>
           <a:xfrm>
-            <a:off x="4754880" y="1920240"/>
+            <a:off x="365760" y="2859258"/>
             <a:ext cx="4389120" cy="1554480"/>
           </a:xfrm>
           <a:prstGeom prst="rect">
@@ -3637,6 +2997,36 @@
           </a:p>
         </p:txBody>
       </p:sp>
+      <p:pic>
+        <p:nvPicPr>
+          <p:cNvPr id="16" name="Immagine 15">
+            <a:extLst>
+              <a:ext uri="{FF2B5EF4-FFF2-40B4-BE49-F238E27FC236}">
+                <a16:creationId xmlns:a16="http://schemas.microsoft.com/office/drawing/2014/main" id="{2A4C0EFF-F07E-D63C-6411-B341F2CB97BC}"/>
+              </a:ext>
+            </a:extLst>
+          </p:cNvPr>
+          <p:cNvPicPr>
+            <a:picLocks noChangeAspect="1"/>
+          </p:cNvPicPr>
+          <p:nvPr/>
+        </p:nvPicPr>
+        <p:blipFill>
+          <a:blip r:embed="rId3"/>
+          <a:stretch>
+            <a:fillRect/>
+          </a:stretch>
+        </p:blipFill>
+        <p:spPr>
+          <a:xfrm>
+            <a:off x="5697077" y="1917150"/>
+            <a:ext cx="3081163" cy="1469219"/>
+          </a:xfrm>
+          <a:prstGeom prst="rect">
+            <a:avLst/>
+          </a:prstGeom>
+        </p:spPr>
+      </p:pic>
     </p:spTree>
   </p:cSld>
   <p:clrMapOvr>
@@ -5226,17 +4616,6 @@
             <a:pPr marL="0" indent="0">
               <a:buNone/>
             </a:pPr>
-            <a:r>
-              <a:rPr lang="en-US" sz="1100" i="1" dirty="0">
-                <a:solidFill>
-                  <a:srgbClr val="75AADB"/>
-                </a:solidFill>
-                <a:latin typeface="Calibri" pitchFamily="34" charset="0"/>
-                <a:ea typeface="Calibri" pitchFamily="34" charset="-122"/>
-                <a:cs typeface="Calibri" pitchFamily="34" charset="-120"/>
-              </a:rPr>
-              <a:t>pivot · Otamendi</a:t>
-            </a:r>
             <a:endParaRPr lang="en-US" sz="1100" dirty="0"/>
           </a:p>
         </p:txBody>
@@ -5502,17 +4881,6 @@
             <a:pPr marL="0" indent="0">
               <a:buNone/>
             </a:pPr>
-            <a:r>
-              <a:rPr lang="en-US" sz="1100" i="1" dirty="0">
-                <a:solidFill>
-                  <a:srgbClr val="002395"/>
-                </a:solidFill>
-                <a:latin typeface="Calibri" pitchFamily="34" charset="0"/>
-                <a:ea typeface="Calibri" pitchFamily="34" charset="-122"/>
-                <a:cs typeface="Calibri" pitchFamily="34" charset="-120"/>
-              </a:rPr>
-              <a:t>pivot · Tchouaméni</a:t>
-            </a:r>
             <a:endParaRPr lang="en-US" sz="1100" dirty="0"/>
           </a:p>
         </p:txBody>
@@ -5778,17 +5146,6 @@
             <a:pPr marL="0" indent="0">
               <a:buNone/>
             </a:pPr>
-            <a:r>
-              <a:rPr lang="en-US" sz="1100" i="1" dirty="0">
-                <a:solidFill>
-                  <a:srgbClr val="C44E52"/>
-                </a:solidFill>
-                <a:latin typeface="Calibri" pitchFamily="34" charset="0"/>
-                <a:ea typeface="Calibri" pitchFamily="34" charset="-122"/>
-                <a:cs typeface="Calibri" pitchFamily="34" charset="-120"/>
-              </a:rPr>
-              <a:t>pivot · Modrić</a:t>
-            </a:r>
             <a:endParaRPr lang="en-US" sz="1100" dirty="0"/>
           </a:p>
         </p:txBody>
@@ -5955,7 +5312,7 @@
           <a:bodyPr/>
           <a:lstStyle/>
           <a:p>
-            <a:endParaRPr lang="it-IT"/>
+            <a:endParaRPr lang="it-IT" dirty="0"/>
           </a:p>
         </p:txBody>
       </p:sp>
@@ -6054,17 +5411,6 @@
             <a:pPr marL="0" indent="0">
               <a:buNone/>
             </a:pPr>
-            <a:r>
-              <a:rPr lang="en-US" sz="1100" i="1" dirty="0">
-                <a:solidFill>
-                  <a:srgbClr val="006233"/>
-                </a:solidFill>
-                <a:latin typeface="Calibri" pitchFamily="34" charset="0"/>
-                <a:ea typeface="Calibri" pitchFamily="34" charset="-122"/>
-                <a:cs typeface="Calibri" pitchFamily="34" charset="-120"/>
-              </a:rPr>
-              <a:t>pivot · Amrabat</a:t>
-            </a:r>
             <a:endParaRPr lang="en-US" sz="1100" dirty="0"/>
           </a:p>
         </p:txBody>
@@ -10927,7 +10273,7 @@
           <a:bodyPr/>
           <a:lstStyle/>
           <a:p>
-            <a:endParaRPr lang="it-IT"/>
+            <a:endParaRPr lang="it-IT" dirty="0"/>
           </a:p>
         </p:txBody>
       </p:sp>
@@ -10964,7 +10310,7 @@
                 <a:ea typeface="Cambria" pitchFamily="34" charset="-122"/>
                 <a:cs typeface="Cambria" pitchFamily="34" charset="-120"/>
               </a:rPr>
-              <a:t>9</a:t>
+              <a:t>8</a:t>
             </a:r>
             <a:endParaRPr lang="en-US" sz="1800" dirty="0"/>
           </a:p>
@@ -10991,19 +10337,9 @@
           <a:bodyPr wrap="square" lIns="0" tIns="0" rIns="0" bIns="0" rtlCol="0" anchor="ctr"/>
           <a:lstStyle/>
           <a:p>
-            <a:pPr marL="0" indent="0" algn="l">
-              <a:buNone/>
-            </a:pPr>
-            <a:r>
-              <a:rPr lang="en-US" sz="2400" b="1" dirty="0">
-                <a:solidFill>
-                  <a:srgbClr val="0F172A"/>
-                </a:solidFill>
-                <a:latin typeface="Cambria" pitchFamily="34" charset="0"/>
-                <a:ea typeface="Cambria" pitchFamily="34" charset="-122"/>
-                <a:cs typeface="Cambria" pitchFamily="34" charset="-120"/>
-              </a:rPr>
-              <a:t>Come lo visualizziamo</a:t>
+            <a:r>
+              <a:rPr lang="it-IT" sz="2400" dirty="0"/>
+              <a:t>Strategia di Visualizzazione</a:t>
             </a:r>
             <a:endParaRPr lang="en-US" sz="2400" dirty="0"/>
           </a:p>
@@ -11017,8 +10353,8 @@
         </p:nvSpPr>
         <p:spPr>
           <a:xfrm>
-            <a:off x="2514987" y="1054660"/>
-            <a:ext cx="4023360" cy="3200400"/>
+            <a:off x="914401" y="1054660"/>
+            <a:ext cx="7315199" cy="3200400"/>
           </a:xfrm>
           <a:prstGeom prst="rect">
             <a:avLst/>
@@ -11037,7 +10373,88 @@
           <a:bodyPr/>
           <a:lstStyle/>
           <a:p>
-            <a:endParaRPr lang="it-IT"/>
+            <a:endParaRPr lang="it-IT" b="1" dirty="0"/>
+          </a:p>
+          <a:p>
+            <a:endParaRPr lang="it-IT" b="1" dirty="0"/>
+          </a:p>
+          <a:p>
+            <a:r>
+              <a:rPr lang="it-IT" b="1" dirty="0"/>
+              <a:t>Hero Figures Statiche (RQ1):</a:t>
+            </a:r>
+            <a:r>
+              <a:rPr lang="it-IT" dirty="0"/>
+              <a:t> Mappe spaziali su </a:t>
+            </a:r>
+            <a:r>
+              <a:rPr lang="it-IT" dirty="0" err="1"/>
+              <a:t>grid</a:t>
+            </a:r>
+            <a:r>
+              <a:rPr lang="it-IT" dirty="0"/>
+              <a:t> 2x2. I nodi sono posizionati sulle coordinate medie reali (</a:t>
+            </a:r>
+            <a:r>
+              <a:rPr lang="it-IT" dirty="0" err="1"/>
+              <a:t>x,y</a:t>
+            </a:r>
+            <a:r>
+              <a:rPr lang="it-IT" dirty="0"/>
+              <a:t>) sul campo. La grandezza del nodo evidenzia la sua </a:t>
+            </a:r>
+            <a:r>
+              <a:rPr lang="it-IT" i="1" dirty="0" err="1"/>
+              <a:t>Betweenness</a:t>
+            </a:r>
+            <a:r>
+              <a:rPr lang="it-IT" dirty="0"/>
+              <a:t>.</a:t>
+            </a:r>
+          </a:p>
+          <a:p>
+            <a:r>
+              <a:rPr lang="it-IT" b="1" dirty="0"/>
+              <a:t>Matrici e </a:t>
+            </a:r>
+            <a:r>
+              <a:rPr lang="it-IT" b="1" dirty="0" err="1"/>
+              <a:t>Heatmaps</a:t>
+            </a:r>
+            <a:r>
+              <a:rPr lang="it-IT" b="1" dirty="0"/>
+              <a:t> (RQ2):</a:t>
+            </a:r>
+            <a:r>
+              <a:rPr lang="it-IT" dirty="0"/>
+              <a:t> </a:t>
+            </a:r>
+            <a:r>
+              <a:rPr lang="it-IT" dirty="0" err="1"/>
+              <a:t>Heatmap</a:t>
+            </a:r>
+            <a:r>
+              <a:rPr lang="it-IT" dirty="0"/>
+              <a:t> per visualizzare le divergenze di centralità e matrici di confusione per confrontare gli algoritmi con la </a:t>
+            </a:r>
+            <a:r>
+              <a:rPr lang="it-IT" i="1" dirty="0"/>
+              <a:t>Ground Truth</a:t>
+            </a:r>
+            <a:r>
+              <a:rPr lang="it-IT" dirty="0"/>
+              <a:t> tattica.</a:t>
+            </a:r>
+          </a:p>
+          <a:p>
+            <a:r>
+              <a:rPr lang="it-IT" b="1" dirty="0"/>
+              <a:t>Curve di Robustezza (RQ3): </a:t>
+            </a:r>
+            <a:r>
+              <a:rPr lang="it-IT" dirty="0"/>
+              <a:t>Istogrammi delle 200 rimozioni casuali con evidenziata la caduta d'efficienza del pivot.</a:t>
+            </a:r>
           </a:p>
         </p:txBody>
       </p:sp>
@@ -11049,8 +10466,8 @@
         </p:nvSpPr>
         <p:spPr>
           <a:xfrm>
-            <a:off x="2514987" y="1054660"/>
-            <a:ext cx="4023360" cy="502920"/>
+            <a:off x="914400" y="1054660"/>
+            <a:ext cx="7315200" cy="502920"/>
           </a:xfrm>
           <a:prstGeom prst="rect">
             <a:avLst/>
@@ -11136,17 +10553,6 @@
               </a:spcAft>
               <a:buNone/>
             </a:pPr>
-            <a:r>
-              <a:rPr lang="en-US" sz="1200" dirty="0">
-                <a:solidFill>
-                  <a:srgbClr val="0F172A"/>
-                </a:solidFill>
-                <a:latin typeface="Calibri" pitchFamily="34" charset="0"/>
-                <a:ea typeface="Calibri" pitchFamily="34" charset="-122"/>
-                <a:cs typeface="Calibri" pitchFamily="34" charset="-120"/>
-              </a:rPr>
-              <a:t>Notebook Jupyter eseguibili, una figura hero per RQ1, una matrice di confusione per RQ2, gli istogrammi delle 200 rimozioni per RQ3, e una flagship composite finale che lega tutto.</a:t>
-            </a:r>
             <a:endParaRPr lang="en-US" sz="1200" dirty="0"/>
           </a:p>
         </p:txBody>

</xml_diff>